<commit_message>
Updated readme and added requirements.txt
</commit_message>
<xml_diff>
--- a/PowerPoint/Crop Prediction Using Climate Forecasting.pptx
+++ b/PowerPoint/Crop Prediction Using Climate Forecasting.pptx
@@ -5538,8 +5538,8 @@
         </p:nvSpPr>
         <p:spPr>
           <a:xfrm>
-            <a:off x="4648083" y="3981449"/>
-            <a:ext cx="3286042" cy="228600"/>
+            <a:off x="4648083" y="3949459"/>
+            <a:ext cx="1385444" cy="292581"/>
           </a:xfrm>
           <a:prstGeom prst="rect">
             <a:avLst/>
@@ -5564,14 +5564,29 @@
               </a:spcAft>
             </a:pPr>
             <a:r>
-              <a:rPr sz="956" b="0">
+              <a:rPr sz="956" b="0" dirty="0">
                 <a:solidFill>
                   <a:srgbClr val="FFFFFF"/>
                 </a:solidFill>
                 <a:latin typeface="Roboto Flex"/>
               </a:rPr>
-              <a:t>• Test forecast accuracy</a:t>
-            </a:r>
+              <a:t>• Test </a:t>
+            </a:r>
+            <a:r>
+              <a:rPr lang="en-US" sz="956" b="0" dirty="0">
+                <a:solidFill>
+                  <a:srgbClr val="FFFFFF"/>
+                </a:solidFill>
+                <a:latin typeface="Roboto Flex"/>
+              </a:rPr>
+              <a:t>crop suitability</a:t>
+            </a:r>
+            <a:endParaRPr sz="956" b="0" dirty="0">
+              <a:solidFill>
+                <a:srgbClr val="FFFFFF"/>
+              </a:solidFill>
+              <a:latin typeface="Roboto Flex"/>
+            </a:endParaRPr>
           </a:p>
         </p:txBody>
       </p:sp>
@@ -6792,51 +6807,6 @@
       </p:sp>
       <p:sp>
         <p:nvSpPr>
-          <p:cNvPr id="15" name="TextBox 14"/>
-          <p:cNvSpPr txBox="1"/>
-          <p:nvPr/>
-        </p:nvSpPr>
-        <p:spPr>
-          <a:xfrm>
-            <a:off x="4162320" y="2181225"/>
-            <a:ext cx="7172145" cy="228600"/>
-          </a:xfrm>
-          <a:prstGeom prst="rect">
-            <a:avLst/>
-          </a:prstGeom>
-          <a:noFill/>
-        </p:spPr>
-        <p:txBody>
-          <a:bodyPr wrap="none" lIns="73152" tIns="54864" rIns="73152" bIns="54864" anchor="ctr">
-            <a:spAutoFit/>
-          </a:bodyPr>
-          <a:lstStyle/>
-          <a:p>
-            <a:pPr algn="l">
-              <a:lnSpc>
-                <a:spcPts val="1560"/>
-              </a:lnSpc>
-              <a:spcBef>
-                <a:spcPts val="0"/>
-              </a:spcBef>
-              <a:spcAft>
-                <a:spcPts val="0"/>
-              </a:spcAft>
-            </a:pPr>
-            <a:r>
-              <a:rPr sz="956" b="0">
-                <a:solidFill>
-                  <a:srgbClr val="FFFFFF"/>
-                </a:solidFill>
-                <a:latin typeface="Roboto Flex"/>
-              </a:rPr>
-              <a:t>• Human-centered AI principles</a:t>
-            </a:r>
-          </a:p>
-        </p:txBody>
-      </p:sp>
-      <p:sp>
-        <p:nvSpPr>
           <p:cNvPr id="16" name="Rounded Rectangle 15"/>
           <p:cNvSpPr/>
           <p:nvPr/>
@@ -7054,8 +7024,8 @@
         </p:nvSpPr>
         <p:spPr>
           <a:xfrm>
-            <a:off x="4162320" y="3648074"/>
-            <a:ext cx="7172145" cy="228600"/>
+            <a:off x="4162320" y="3616084"/>
+            <a:ext cx="4757969" cy="292581"/>
           </a:xfrm>
           <a:prstGeom prst="rect">
             <a:avLst/>
@@ -7080,13 +7050,31 @@
               </a:spcAft>
             </a:pPr>
             <a:r>
-              <a:rPr sz="956" b="0">
+              <a:rPr sz="956" b="0" dirty="0">
                 <a:solidFill>
                   <a:srgbClr val="FFFFFF"/>
                 </a:solidFill>
                 <a:latin typeface="Roboto Flex"/>
               </a:rPr>
-              <a:t>• No forward-looking guidance exists — only monitoring and historical analysis</a:t>
+              <a:t>• No forward-looking guidance </a:t>
+            </a:r>
+            <a:r>
+              <a:rPr lang="en-US" sz="956" dirty="0">
+                <a:solidFill>
+                  <a:srgbClr val="FFFFFF"/>
+                </a:solidFill>
+                <a:latin typeface="Roboto Flex"/>
+              </a:rPr>
+              <a:t>systems exists,</a:t>
+            </a:r>
+            <a:r>
+              <a:rPr sz="956" b="0" dirty="0">
+                <a:solidFill>
+                  <a:srgbClr val="FFFFFF"/>
+                </a:solidFill>
+                <a:latin typeface="Roboto Flex"/>
+              </a:rPr>
+              <a:t> only monitoring and historical analysis</a:t>
             </a:r>
           </a:p>
         </p:txBody>
@@ -7099,8 +7087,8 @@
         </p:nvSpPr>
         <p:spPr>
           <a:xfrm>
-            <a:off x="4162320" y="3933824"/>
-            <a:ext cx="7172145" cy="228600"/>
+            <a:off x="4162320" y="3901834"/>
+            <a:ext cx="2507353" cy="292581"/>
           </a:xfrm>
           <a:prstGeom prst="rect">
             <a:avLst/>
@@ -7125,7 +7113,7 @@
               </a:spcAft>
             </a:pPr>
             <a:r>
-              <a:rPr sz="956" b="0">
+              <a:rPr sz="956" b="0" dirty="0">
                 <a:solidFill>
                   <a:srgbClr val="FFFFFF"/>
                 </a:solidFill>
@@ -7134,7 +7122,7 @@
               <a:t>• </a:t>
             </a:r>
             <a:r>
-              <a:rPr sz="956" b="1">
+              <a:rPr sz="956" b="1" dirty="0">
                 <a:solidFill>
                   <a:srgbClr val="37DCF2"/>
                 </a:solidFill>
@@ -7142,15 +7130,12 @@
               </a:rPr>
               <a:t>Few systems use predictive modeling</a:t>
             </a:r>
-            <a:r>
-              <a:rPr sz="956" b="0">
-                <a:solidFill>
-                  <a:srgbClr val="FFFFFF"/>
-                </a:solidFill>
-                <a:latin typeface="Roboto Flex"/>
-              </a:rPr>
-              <a:t> (under 10% of agricultural apps)</a:t>
-            </a:r>
+            <a:endParaRPr sz="956" b="0" dirty="0">
+              <a:solidFill>
+                <a:srgbClr val="FFFFFF"/>
+              </a:solidFill>
+              <a:latin typeface="Roboto Flex"/>
+            </a:endParaRPr>
           </a:p>
         </p:txBody>
       </p:sp>

</xml_diff>